<commit_message>
Apply three content fixes to both inception reports
Fix 1 — UDC categorisation:
- Moved Uganda Development Corporation (UDC) from 'Industry associations'
  to 'Financial Institutions' in both reports
- Renamed category from 'Financiers' to 'Financial Institutions'
- Applied to Report 1 and Report 2 KII tables and both presentations

Fix 2 — Numeric weights:
- Renamed 'Proposed Weight' column to 'Weight' in both reports
- Weights (25/25/20/15/15%) were endorsed in the 29 May dry-run

Fix 3 — Remove attribution:
- Removed 'as stated by Jerome Nuwabaasa' from the analytical principle
  quote in both reports and both presentations

All Word documents and PowerPoint presentations regenerated.

Co-Authored-By: Claude Sonnet 4.6 <noreply@anthropic.com>
</commit_message>
<xml_diff>
--- a/report/inception-report-1.pptx
+++ b/report/inception-report-1.pptx
@@ -5328,7 +5328,7 @@
                             <a:srgbClr val="333333"/>
                           </a:solidFill>
                         </a:rPr>
-                        <a:t>Uganda Manufacturers Association (UMA), Uganda Development Corporation (UDC)</a:t>
+                        <a:t>Uganda Manufacturers Association (UMA)</a:t>
                       </a:r>
                     </a:p>
                   </a:txBody>
@@ -5374,7 +5374,7 @@
                             <a:srgbClr val="333333"/>
                           </a:solidFill>
                         </a:rPr>
-                        <a:t>Financiers</a:t>
+                        <a:t>Financial Institutions</a:t>
                       </a:r>
                     </a:p>
                   </a:txBody>
@@ -5396,7 +5396,7 @@
                             <a:srgbClr val="333333"/>
                           </a:solidFill>
                         </a:rPr>
-                        <a:t>Uganda Development Bank (UDB), EADB, commercial banks</a:t>
+                        <a:t>Uganda Development Bank (UDB), Uganda Development Corporation (UDC), East African Development Bank (EADB), commercial banks</a:t>
                       </a:r>
                     </a:p>
                   </a:txBody>
@@ -7511,14 +7511,6 @@
           </a:p>
           <a:p>
             <a:pPr/>
-            <a:r>
-              <a:rPr sz="1600" b="0">
-                <a:solidFill>
-                  <a:srgbClr val="333333"/>
-                </a:solidFill>
-              </a:rPr>
-              <a:t>                                                                    — Jerome Nuwabaasa, MTIC</a:t>
-            </a:r>
           </a:p>
           <a:p>
             <a:pPr/>

</xml_diff>